<commit_message>
Extracting Training Data from Diffusion Models
</commit_message>
<xml_diff>
--- a/Attack/Backdoor_Attack/论文作图.pptx
+++ b/Attack/Backdoor_Attack/论文作图.pptx
@@ -3603,7 +3603,7 @@
         </p:blipFill>
         <p:spPr>
           <a:xfrm>
-            <a:off x="514350" y="1866900"/>
+            <a:off x="514350" y="231775"/>
             <a:ext cx="11163300" cy="3124200"/>
           </a:xfrm>
           <a:prstGeom prst="rect">
@@ -3611,136 +3611,19 @@
           </a:prstGeom>
         </p:spPr>
       </p:pic>
-      <p:pic>
-        <p:nvPicPr>
-          <p:cNvPr id="5" name="图片 4"/>
-          <p:cNvPicPr>
-            <a:picLocks noChangeAspect="1"/>
-          </p:cNvPicPr>
+      <p:sp>
+        <p:nvSpPr>
+          <p:cNvPr id="7" name="文本框 6"/>
+          <p:cNvSpPr txBox="1"/>
           <p:nvPr>
             <p:custDataLst>
               <p:tags r:id="rId3"/>
             </p:custDataLst>
           </p:nvPr>
-        </p:nvPicPr>
-        <p:blipFill>
-          <a:blip r:embed="rId4"/>
-          <a:stretch>
-            <a:fillRect/>
-          </a:stretch>
-        </p:blipFill>
+        </p:nvSpPr>
         <p:spPr>
           <a:xfrm>
-            <a:off x="514350" y="346710"/>
-            <a:ext cx="3886200" cy="622300"/>
-          </a:xfrm>
-          <a:prstGeom prst="rect">
-            <a:avLst/>
-          </a:prstGeom>
-        </p:spPr>
-      </p:pic>
-      <p:sp>
-        <p:nvSpPr>
-          <p:cNvPr id="30" name="文本框 29"/>
-          <p:cNvSpPr txBox="1"/>
-          <p:nvPr>
-            <p:custDataLst>
-              <p:tags r:id="rId5"/>
-            </p:custDataLst>
-          </p:nvPr>
-        </p:nvSpPr>
-        <p:spPr>
-          <a:xfrm>
-            <a:off x="4578985" y="274320"/>
-            <a:ext cx="2799715" cy="548640"/>
-          </a:xfrm>
-          <a:prstGeom prst="rect">
-            <a:avLst/>
-          </a:prstGeom>
-          <a:noFill/>
-        </p:spPr>
-        <p:txBody>
-          <a:bodyPr wrap="square" rtlCol="0">
-            <a:noAutofit/>
-          </a:bodyPr>
-          <a:p>
-            <a:pPr algn="ctr"/>
-            <a:r>
-              <a:rPr lang="zh-CN" altLang="en-US" sz="1200" b="1">
-                <a:latin typeface="微软雅黑" charset="0"/>
-                <a:ea typeface="微软雅黑" charset="0"/>
-                <a:cs typeface="微软雅黑" charset="0"/>
-              </a:rPr>
-              <a:t>分类正确为</a:t>
-            </a:r>
-            <a:r>
-              <a:rPr lang="en-US" altLang="zh-CN" sz="1200" b="1">
-                <a:latin typeface="微软雅黑" charset="0"/>
-                <a:ea typeface="微软雅黑" charset="0"/>
-                <a:cs typeface="微软雅黑" charset="0"/>
-              </a:rPr>
-              <a:t>1</a:t>
-            </a:r>
-            <a:r>
-              <a:rPr lang="zh-CN" altLang="en-US" sz="1200" b="1">
-                <a:latin typeface="微软雅黑" charset="0"/>
-                <a:ea typeface="微软雅黑" charset="0"/>
-                <a:cs typeface="微软雅黑" charset="0"/>
-              </a:rPr>
-              <a:t>，错误为</a:t>
-            </a:r>
-            <a:r>
-              <a:rPr lang="en-US" altLang="zh-CN" sz="1200" b="1">
-                <a:latin typeface="微软雅黑" charset="0"/>
-                <a:ea typeface="微软雅黑" charset="0"/>
-                <a:cs typeface="微软雅黑" charset="0"/>
-              </a:rPr>
-              <a:t>0</a:t>
-            </a:r>
-            <a:br>
-              <a:rPr lang="en-US" altLang="zh-CN" sz="1200" b="1">
-                <a:latin typeface="微软雅黑" charset="0"/>
-                <a:ea typeface="微软雅黑" charset="0"/>
-                <a:cs typeface="微软雅黑" charset="0"/>
-              </a:rPr>
-            </a:br>
-            <a:r>
-              <a:rPr lang="zh-CN" altLang="en-US" sz="1200" b="1">
-                <a:latin typeface="微软雅黑" charset="0"/>
-                <a:ea typeface="微软雅黑" charset="0"/>
-                <a:cs typeface="微软雅黑" charset="0"/>
-              </a:rPr>
-              <a:t>最大化正常分类正确和后门分类</a:t>
-            </a:r>
-            <a:r>
-              <a:rPr lang="zh-CN" altLang="en-US" sz="1200" b="1">
-                <a:latin typeface="微软雅黑" charset="0"/>
-                <a:ea typeface="微软雅黑" charset="0"/>
-                <a:cs typeface="微软雅黑" charset="0"/>
-              </a:rPr>
-              <a:t>错误</a:t>
-            </a:r>
-            <a:endParaRPr lang="zh-CN" altLang="en-US" sz="1200" b="1">
-              <a:latin typeface="微软雅黑" charset="0"/>
-              <a:ea typeface="微软雅黑" charset="0"/>
-              <a:cs typeface="微软雅黑" charset="0"/>
-            </a:endParaRPr>
-          </a:p>
-        </p:txBody>
-      </p:sp>
-      <p:sp>
-        <p:nvSpPr>
-          <p:cNvPr id="7" name="文本框 6"/>
-          <p:cNvSpPr txBox="1"/>
-          <p:nvPr>
-            <p:custDataLst>
-              <p:tags r:id="rId6"/>
-            </p:custDataLst>
-          </p:nvPr>
-        </p:nvSpPr>
-        <p:spPr>
-          <a:xfrm>
-            <a:off x="311150" y="6035040"/>
+            <a:off x="1581150" y="4384040"/>
             <a:ext cx="3298825" cy="548640"/>
           </a:xfrm>
           <a:prstGeom prst="rect">
@@ -3809,19 +3692,19 @@
           </p:cNvPicPr>
           <p:nvPr>
             <p:custDataLst>
-              <p:tags r:id="rId7"/>
+              <p:tags r:id="rId4"/>
             </p:custDataLst>
           </p:nvPr>
         </p:nvPicPr>
         <p:blipFill>
-          <a:blip r:embed="rId8"/>
+          <a:blip r:embed="rId5"/>
           <a:stretch>
             <a:fillRect/>
           </a:stretch>
         </p:blipFill>
         <p:spPr>
           <a:xfrm>
-            <a:off x="0" y="5325110"/>
+            <a:off x="1270000" y="3674110"/>
             <a:ext cx="4226560" cy="577850"/>
           </a:xfrm>
           <a:prstGeom prst="rect">
@@ -3837,6 +3720,107 @@
           </p:cNvPicPr>
           <p:nvPr>
             <p:custDataLst>
+              <p:tags r:id="rId6"/>
+            </p:custDataLst>
+          </p:nvPr>
+        </p:nvPicPr>
+        <p:blipFill>
+          <a:blip r:embed="rId7"/>
+          <a:stretch>
+            <a:fillRect/>
+          </a:stretch>
+        </p:blipFill>
+        <p:spPr>
+          <a:xfrm>
+            <a:off x="7064375" y="3489960"/>
+            <a:ext cx="4241800" cy="635000"/>
+          </a:xfrm>
+          <a:prstGeom prst="rect">
+            <a:avLst/>
+          </a:prstGeom>
+        </p:spPr>
+      </p:pic>
+      <p:sp>
+        <p:nvSpPr>
+          <p:cNvPr id="10" name="文本框 9"/>
+          <p:cNvSpPr txBox="1"/>
+          <p:nvPr>
+            <p:custDataLst>
+              <p:tags r:id="rId8"/>
+            </p:custDataLst>
+          </p:nvPr>
+        </p:nvSpPr>
+        <p:spPr>
+          <a:xfrm>
+            <a:off x="7089140" y="4257040"/>
+            <a:ext cx="3357880" cy="548640"/>
+          </a:xfrm>
+          <a:prstGeom prst="rect">
+            <a:avLst/>
+          </a:prstGeom>
+          <a:noFill/>
+        </p:spPr>
+        <p:txBody>
+          <a:bodyPr wrap="square" rtlCol="0">
+            <a:noAutofit/>
+          </a:bodyPr>
+          <a:p>
+            <a:pPr algn="ctr"/>
+            <a:r>
+              <a:rPr lang="zh-CN" altLang="en-US" sz="1200" b="1">
+                <a:latin typeface="微软雅黑" charset="0"/>
+                <a:ea typeface="微软雅黑" charset="0"/>
+                <a:cs typeface="微软雅黑" charset="0"/>
+              </a:rPr>
+              <a:t>攻击后不可区分性</a:t>
+            </a:r>
+            <a:br>
+              <a:rPr lang="zh-CN" altLang="en-US" sz="1200" b="1">
+                <a:latin typeface="微软雅黑" charset="0"/>
+                <a:ea typeface="微软雅黑" charset="0"/>
+                <a:cs typeface="微软雅黑" charset="0"/>
+              </a:rPr>
+            </a:br>
+            <a:r>
+              <a:rPr lang="zh-CN" altLang="en-US" sz="1200" b="1">
+                <a:latin typeface="微软雅黑" charset="0"/>
+                <a:ea typeface="微软雅黑" charset="0"/>
+                <a:cs typeface="微软雅黑" charset="0"/>
+              </a:rPr>
+              <a:t>对于正常训练集和影子训练集中的样本，最大化后门</a:t>
+            </a:r>
+            <a:r>
+              <a:rPr lang="zh-CN" altLang="en-US" sz="1200" b="1">
+                <a:latin typeface="微软雅黑" charset="0"/>
+                <a:ea typeface="微软雅黑" charset="0"/>
+                <a:cs typeface="微软雅黑" charset="0"/>
+              </a:rPr>
+              <a:t>模型植入后门和干净样本的余弦</a:t>
+            </a:r>
+            <a:r>
+              <a:rPr lang="zh-CN" altLang="en-US" sz="1200" b="1">
+                <a:latin typeface="微软雅黑" charset="0"/>
+                <a:ea typeface="微软雅黑" charset="0"/>
+                <a:cs typeface="微软雅黑" charset="0"/>
+              </a:rPr>
+              <a:t>相似度</a:t>
+            </a:r>
+            <a:endParaRPr lang="zh-CN" altLang="en-US" sz="1200" b="1">
+              <a:latin typeface="微软雅黑" charset="0"/>
+              <a:ea typeface="微软雅黑" charset="0"/>
+              <a:cs typeface="微软雅黑" charset="0"/>
+            </a:endParaRPr>
+          </a:p>
+        </p:txBody>
+      </p:sp>
+      <p:pic>
+        <p:nvPicPr>
+          <p:cNvPr id="11" name="图片 10"/>
+          <p:cNvPicPr>
+            <a:picLocks noChangeAspect="1"/>
+          </p:cNvPicPr>
+          <p:nvPr>
+            <p:custDataLst>
               <p:tags r:id="rId9"/>
             </p:custDataLst>
           </p:nvPr>
@@ -3849,28 +3833,112 @@
         </p:blipFill>
         <p:spPr>
           <a:xfrm>
-            <a:off x="5104765" y="5267960"/>
-            <a:ext cx="4241800" cy="635000"/>
+            <a:off x="1581150" y="5179060"/>
+            <a:ext cx="3035300" cy="622300"/>
           </a:xfrm>
           <a:prstGeom prst="rect">
             <a:avLst/>
           </a:prstGeom>
         </p:spPr>
       </p:pic>
-      <p:sp>
-        <p:nvSpPr>
-          <p:cNvPr id="10" name="文本框 9"/>
-          <p:cNvSpPr txBox="1"/>
+      <p:pic>
+        <p:nvPicPr>
+          <p:cNvPr id="12" name="图片 11"/>
+          <p:cNvPicPr>
+            <a:picLocks noChangeAspect="1"/>
+          </p:cNvPicPr>
           <p:nvPr>
             <p:custDataLst>
               <p:tags r:id="rId11"/>
             </p:custDataLst>
           </p:nvPr>
-        </p:nvSpPr>
+        </p:nvPicPr>
+        <p:blipFill>
+          <a:blip r:embed="rId12"/>
+          <a:stretch>
+            <a:fillRect/>
+          </a:stretch>
+        </p:blipFill>
         <p:spPr>
           <a:xfrm>
-            <a:off x="5129530" y="6035040"/>
-            <a:ext cx="3357880" cy="548640"/>
+            <a:off x="5640070" y="5102860"/>
+            <a:ext cx="3086100" cy="635000"/>
+          </a:xfrm>
+          <a:prstGeom prst="rect">
+            <a:avLst/>
+          </a:prstGeom>
+        </p:spPr>
+      </p:pic>
+      <p:pic>
+        <p:nvPicPr>
+          <p:cNvPr id="13" name="图片 12"/>
+          <p:cNvPicPr>
+            <a:picLocks noChangeAspect="1"/>
+          </p:cNvPicPr>
+          <p:nvPr>
+            <p:custDataLst>
+              <p:tags r:id="rId13"/>
+            </p:custDataLst>
+          </p:nvPr>
+        </p:nvPicPr>
+        <p:blipFill>
+          <a:blip r:embed="rId14"/>
+          <a:stretch>
+            <a:fillRect/>
+          </a:stretch>
+        </p:blipFill>
+        <p:spPr>
+          <a:xfrm>
+            <a:off x="9398000" y="5140960"/>
+            <a:ext cx="2794000" cy="596900"/>
+          </a:xfrm>
+          <a:prstGeom prst="rect">
+            <a:avLst/>
+          </a:prstGeom>
+        </p:spPr>
+      </p:pic>
+      <p:pic>
+        <p:nvPicPr>
+          <p:cNvPr id="14" name="图片 13"/>
+          <p:cNvPicPr>
+            <a:picLocks noChangeAspect="1"/>
+          </p:cNvPicPr>
+          <p:nvPr>
+            <p:custDataLst>
+              <p:tags r:id="rId15"/>
+            </p:custDataLst>
+          </p:nvPr>
+        </p:nvPicPr>
+        <p:blipFill>
+          <a:blip r:embed="rId16"/>
+          <a:stretch>
+            <a:fillRect/>
+          </a:stretch>
+        </p:blipFill>
+        <p:spPr>
+          <a:xfrm>
+            <a:off x="7856220" y="6073140"/>
+            <a:ext cx="2590800" cy="622300"/>
+          </a:xfrm>
+          <a:prstGeom prst="rect">
+            <a:avLst/>
+          </a:prstGeom>
+        </p:spPr>
+      </p:pic>
+      <p:sp>
+        <p:nvSpPr>
+          <p:cNvPr id="15" name="文本框 14"/>
+          <p:cNvSpPr txBox="1"/>
+          <p:nvPr>
+            <p:custDataLst>
+              <p:tags r:id="rId17"/>
+            </p:custDataLst>
+          </p:nvPr>
+        </p:nvSpPr>
+        <p:spPr>
+          <a:xfrm>
+            <a:off x="1454150" y="5908040"/>
+            <a:ext cx="3298825" cy="548640"/>
           </a:xfrm>
           <a:prstGeom prst="rect">
             <a:avLst/>
@@ -3889,38 +3957,65 @@
                 <a:ea typeface="微软雅黑" charset="0"/>
                 <a:cs typeface="微软雅黑" charset="0"/>
               </a:rPr>
-              <a:t>攻击后不可区分性</a:t>
-            </a:r>
-            <a:br>
+              <a:t>优化带触发器的模型特征与干净特征之间的余弦相似度</a:t>
+            </a:r>
+            <a:endParaRPr lang="zh-CN" altLang="en-US" sz="1200" b="1">
+              <a:latin typeface="微软雅黑" charset="0"/>
+              <a:ea typeface="微软雅黑" charset="0"/>
+              <a:cs typeface="微软雅黑" charset="0"/>
+            </a:endParaRPr>
+          </a:p>
+        </p:txBody>
+      </p:sp>
+      <p:sp>
+        <p:nvSpPr>
+          <p:cNvPr id="16" name="文本框 15"/>
+          <p:cNvSpPr txBox="1"/>
+          <p:nvPr>
+            <p:custDataLst>
+              <p:tags r:id="rId18"/>
+            </p:custDataLst>
+          </p:nvPr>
+        </p:nvSpPr>
+        <p:spPr>
+          <a:xfrm>
+            <a:off x="5497195" y="5654040"/>
+            <a:ext cx="6694805" cy="548640"/>
+          </a:xfrm>
+          <a:prstGeom prst="rect">
+            <a:avLst/>
+          </a:prstGeom>
+          <a:noFill/>
+        </p:spPr>
+        <p:txBody>
+          <a:bodyPr wrap="square" rtlCol="0">
+            <a:noAutofit/>
+          </a:bodyPr>
+          <a:p>
+            <a:pPr algn="ctr"/>
+            <a:r>
               <a:rPr lang="zh-CN" altLang="en-US" sz="1200" b="1">
                 <a:latin typeface="微软雅黑" charset="0"/>
                 <a:ea typeface="微软雅黑" charset="0"/>
                 <a:cs typeface="微软雅黑" charset="0"/>
               </a:rPr>
-            </a:br>
+              <a:t>在后门模型上带触发器的样本特征与攻击者想要特征的余弦相似度</a:t>
+            </a:r>
+            <a:endParaRPr lang="zh-CN" altLang="en-US" sz="1200" b="1">
+              <a:latin typeface="微软雅黑" charset="0"/>
+              <a:ea typeface="微软雅黑" charset="0"/>
+              <a:cs typeface="微软雅黑" charset="0"/>
+            </a:endParaRPr>
+          </a:p>
+          <a:p>
+            <a:pPr algn="ctr"/>
             <a:r>
               <a:rPr lang="zh-CN" altLang="en-US" sz="1200" b="1">
                 <a:latin typeface="微软雅黑" charset="0"/>
                 <a:ea typeface="微软雅黑" charset="0"/>
                 <a:cs typeface="微软雅黑" charset="0"/>
               </a:rPr>
-              <a:t>对于正常训练集和影子训练集中的样本，最大化后门</a:t>
-            </a:r>
-            <a:r>
-              <a:rPr lang="zh-CN" altLang="en-US" sz="1200" b="1">
-                <a:latin typeface="微软雅黑" charset="0"/>
-                <a:ea typeface="微软雅黑" charset="0"/>
-                <a:cs typeface="微软雅黑" charset="0"/>
-              </a:rPr>
-              <a:t>模型植入后门和干净样本的余弦</a:t>
-            </a:r>
-            <a:r>
-              <a:rPr lang="zh-CN" altLang="en-US" sz="1200" b="1">
-                <a:latin typeface="微软雅黑" charset="0"/>
-                <a:ea typeface="微软雅黑" charset="0"/>
-                <a:cs typeface="微软雅黑" charset="0"/>
-              </a:rPr>
-              <a:t>相似度</a:t>
+              <a:t>不带触发器的样本和正常类别的余弦相似度</a:t>
             </a:r>
             <a:endParaRPr lang="zh-CN" altLang="en-US" sz="1200" b="1">
               <a:latin typeface="微软雅黑" charset="0"/>
@@ -3939,6 +4034,18 @@
 </file>
 
 <file path=ppt/tags/tag1.xml><?xml version="1.0" encoding="utf-8"?>
+<p:tagLst xmlns:p="http://schemas.openxmlformats.org/presentationml/2006/main">
+  <p:tag name="KSO_WM_BEAUTIFY_FLAG" val=""/>
+</p:tagLst>
+</file>
+
+<file path=ppt/tags/tag10.xml><?xml version="1.0" encoding="utf-8"?>
+<p:tagLst xmlns:p="http://schemas.openxmlformats.org/presentationml/2006/main">
+  <p:tag name="KSO_WM_BEAUTIFY_FLAG" val=""/>
+</p:tagLst>
+</file>
+
+<file path=ppt/tags/tag11.xml><?xml version="1.0" encoding="utf-8"?>
 <p:tagLst xmlns:p="http://schemas.openxmlformats.org/presentationml/2006/main">
   <p:tag name="KSO_WM_BEAUTIFY_FLAG" val=""/>
 </p:tagLst>
@@ -3975,6 +4082,18 @@
 </file>
 
 <file path=ppt/tags/tag7.xml><?xml version="1.0" encoding="utf-8"?>
+<p:tagLst xmlns:p="http://schemas.openxmlformats.org/presentationml/2006/main">
+  <p:tag name="KSO_WM_BEAUTIFY_FLAG" val=""/>
+</p:tagLst>
+</file>
+
+<file path=ppt/tags/tag8.xml><?xml version="1.0" encoding="utf-8"?>
+<p:tagLst xmlns:p="http://schemas.openxmlformats.org/presentationml/2006/main">
+  <p:tag name="KSO_WM_BEAUTIFY_FLAG" val=""/>
+</p:tagLst>
+</file>
+
+<file path=ppt/tags/tag9.xml><?xml version="1.0" encoding="utf-8"?>
 <p:tagLst xmlns:p="http://schemas.openxmlformats.org/presentationml/2006/main">
   <p:tag name="KSO_WM_BEAUTIFY_FLAG" val=""/>
 </p:tagLst>

</xml_diff>